<commit_message>
v3.15.04: embed OCR training pages, promo 60s copy
- Add train-ocr / train-ocr5 routes (ocr9/ocr5 workbenches in main app)
- ocr9/ocr10 embed-safe page_config; align titles to ocr.py/ocr5
- Promo PPT: pain slide order, 15s→60s, automation copy
- VERSION / CHANGELOG / README / package.json → 3.15.04
</commit_message>
<xml_diff>
--- a/promo_assets/promo.pptx
+++ b/promo_assets/promo.pptx
@@ -2395,26 +2395,42 @@
       </p:grpSpPr>
       <p:sp>
         <p:nvSpPr>
-          <p:cNvPr id="2" name="Shape 0"/>
-          <p:cNvSpPr/>
-          <p:nvPr/>
-        </p:nvSpPr>
-        <p:spPr>
-          <a:xfrm flipV="1">
-            <a:off x="950976" y="1133856"/>
-            <a:ext cx="1097280" cy="365760"/>
-          </a:xfrm>
-          <a:prstGeom prst="line">
-            <a:avLst/>
-          </a:prstGeom>
-          <a:noFill/>
-          <a:ln w="9525">
-            <a:solidFill>
-              <a:srgbClr val="E5E5EA"/>
-            </a:solidFill>
-            <a:prstDash val="solid"/>
-          </a:ln>
-        </p:spPr>
+          <p:cNvPr id="2" name="Text 0"/>
+          <p:cNvSpPr/>
+          <p:nvPr/>
+        </p:nvSpPr>
+        <p:spPr>
+          <a:xfrm>
+            <a:off x="640080" y="502920"/>
+            <a:ext cx="7772400" cy="411480"/>
+          </a:xfrm>
+          <a:prstGeom prst="rect">
+            <a:avLst/>
+          </a:prstGeom>
+          <a:noFill/>
+          <a:ln/>
+        </p:spPr>
+        <p:txBody>
+          <a:bodyPr wrap="square" lIns="0" tIns="0" rIns="0" bIns="0" rtlCol="0" anchor="ctr"/>
+          <a:lstStyle/>
+          <a:p>
+            <a:pPr indent="0" marL="0">
+              <a:buNone/>
+            </a:pPr>
+            <a:r>
+              <a:rPr lang="en-US" sz="2800" b="1" dirty="0">
+                <a:solidFill>
+                  <a:srgbClr val="111111"/>
+                </a:solidFill>
+                <a:latin typeface="Arial" pitchFamily="34" charset="0"/>
+                <a:ea typeface="Arial" pitchFamily="34" charset="-122"/>
+                <a:cs typeface="Arial" pitchFamily="34" charset="-120"/>
+              </a:rPr>
+              <a:t>人工审核痛点。</a:t>
+            </a:r>
+            <a:endParaRPr lang="en-US" sz="2800" dirty="0"/>
+          </a:p>
+        </p:txBody>
       </p:sp>
       <p:sp>
         <p:nvSpPr>
@@ -2424,19 +2440,28 @@
         </p:nvSpPr>
         <p:spPr>
           <a:xfrm>
-            <a:off x="2048256" y="1133856"/>
-            <a:ext cx="731520" cy="731520"/>
-          </a:xfrm>
-          <a:prstGeom prst="line">
-            <a:avLst/>
-          </a:prstGeom>
-          <a:noFill/>
-          <a:ln w="9525">
-            <a:solidFill>
-              <a:srgbClr val="E5E5EA"/>
-            </a:solidFill>
-            <a:prstDash val="solid"/>
-          </a:ln>
+            <a:off x="640080" y="1371600"/>
+            <a:ext cx="1874520" cy="2194560"/>
+          </a:xfrm>
+          <a:prstGeom prst="rect">
+            <a:avLst/>
+          </a:prstGeom>
+          <a:solidFill>
+            <a:srgbClr val="FFFFFF"/>
+          </a:solidFill>
+          <a:ln w="12700">
+            <a:solidFill>
+              <a:srgbClr val="FFFFFF"/>
+            </a:solidFill>
+            <a:prstDash val="solid"/>
+          </a:ln>
+          <a:effectLst>
+            <a:outerShdw sx="100000" sy="100000" kx="0" ky="0" algn="bl" rotWithShape="0" blurRad="228600" dist="50800" dir="8100000">
+              <a:srgbClr val="000000">
+                <a:alpha val="6000"/>
+              </a:srgbClr>
+            </a:outerShdw>
+          </a:effectLst>
         </p:spPr>
       </p:sp>
       <p:sp>
@@ -2447,66 +2472,100 @@
         </p:nvSpPr>
         <p:spPr>
           <a:xfrm>
-            <a:off x="950976" y="1499616"/>
-            <a:ext cx="1828800" cy="365760"/>
-          </a:xfrm>
-          <a:prstGeom prst="line">
-            <a:avLst/>
-          </a:prstGeom>
-          <a:noFill/>
-          <a:ln w="9525">
-            <a:solidFill>
-              <a:srgbClr val="E5E5EA"/>
-            </a:solidFill>
-            <a:prstDash val="solid"/>
-          </a:ln>
-        </p:spPr>
-      </p:sp>
-      <p:sp>
-        <p:nvSpPr>
-          <p:cNvPr id="5" name="Shape 3"/>
-          <p:cNvSpPr/>
-          <p:nvPr/>
-        </p:nvSpPr>
-        <p:spPr>
-          <a:xfrm>
-            <a:off x="6437376" y="1408176"/>
-            <a:ext cx="1005840" cy="365760"/>
-          </a:xfrm>
-          <a:prstGeom prst="line">
-            <a:avLst/>
-          </a:prstGeom>
-          <a:noFill/>
-          <a:ln w="9525">
-            <a:solidFill>
-              <a:srgbClr val="E5E5EA"/>
-            </a:solidFill>
-            <a:prstDash val="solid"/>
-          </a:ln>
-        </p:spPr>
-      </p:sp>
-      <p:sp>
-        <p:nvSpPr>
-          <p:cNvPr id="6" name="Shape 4"/>
-          <p:cNvSpPr/>
-          <p:nvPr/>
-        </p:nvSpPr>
-        <p:spPr>
-          <a:xfrm flipV="1">
-            <a:off x="7443216" y="1042416"/>
-            <a:ext cx="640080" cy="731520"/>
-          </a:xfrm>
-          <a:prstGeom prst="line">
-            <a:avLst/>
-          </a:prstGeom>
-          <a:noFill/>
-          <a:ln w="9525">
-            <a:solidFill>
-              <a:srgbClr val="E5E5EA"/>
-            </a:solidFill>
-            <a:prstDash val="solid"/>
-          </a:ln>
-        </p:spPr>
+            <a:off x="804672" y="1600200"/>
+            <a:ext cx="109728" cy="109728"/>
+          </a:xfrm>
+          <a:prstGeom prst="rect">
+            <a:avLst/>
+          </a:prstGeom>
+          <a:solidFill>
+            <a:srgbClr val="5B8DEF"/>
+          </a:solidFill>
+          <a:ln w="12700">
+            <a:solidFill>
+              <a:srgbClr val="5B8DEF"/>
+            </a:solidFill>
+            <a:prstDash val="solid"/>
+          </a:ln>
+        </p:spPr>
+      </p:sp>
+      <p:sp>
+        <p:nvSpPr>
+          <p:cNvPr id="5" name="Text 3"/>
+          <p:cNvSpPr/>
+          <p:nvPr/>
+        </p:nvSpPr>
+        <p:spPr>
+          <a:xfrm>
+            <a:off x="804672" y="1965960"/>
+            <a:ext cx="1554480" cy="457200"/>
+          </a:xfrm>
+          <a:prstGeom prst="rect">
+            <a:avLst/>
+          </a:prstGeom>
+          <a:noFill/>
+          <a:ln/>
+        </p:spPr>
+        <p:txBody>
+          <a:bodyPr wrap="square" lIns="0" tIns="0" rIns="0" bIns="0" rtlCol="0" anchor="ctr"/>
+          <a:lstStyle/>
+          <a:p>
+            <a:pPr indent="0" marL="0">
+              <a:buNone/>
+            </a:pPr>
+            <a:r>
+              <a:rPr lang="en-US" sz="2000" b="1" dirty="0">
+                <a:solidFill>
+                  <a:srgbClr val="111111"/>
+                </a:solidFill>
+                <a:latin typeface="Arial" pitchFamily="34" charset="0"/>
+                <a:ea typeface="Arial" pitchFamily="34" charset="-122"/>
+                <a:cs typeface="Arial" pitchFamily="34" charset="-120"/>
+              </a:rPr>
+              <a:t>10 分钟</a:t>
+            </a:r>
+            <a:endParaRPr lang="en-US" sz="2000" dirty="0"/>
+          </a:p>
+        </p:txBody>
+      </p:sp>
+      <p:sp>
+        <p:nvSpPr>
+          <p:cNvPr id="6" name="Text 4"/>
+          <p:cNvSpPr/>
+          <p:nvPr/>
+        </p:nvSpPr>
+        <p:spPr>
+          <a:xfrm>
+            <a:off x="804672" y="2514600"/>
+            <a:ext cx="1554480" cy="731520"/>
+          </a:xfrm>
+          <a:prstGeom prst="rect">
+            <a:avLst/>
+          </a:prstGeom>
+          <a:noFill/>
+          <a:ln/>
+        </p:spPr>
+        <p:txBody>
+          <a:bodyPr wrap="square" lIns="0" tIns="0" rIns="0" bIns="0" rtlCol="0" anchor="ctr"/>
+          <a:lstStyle/>
+          <a:p>
+            <a:pPr indent="0" marL="0">
+              <a:buNone/>
+            </a:pPr>
+            <a:r>
+              <a:rPr lang="en-US" sz="1300" dirty="0">
+                <a:solidFill>
+                  <a:srgbClr val="8E8E93"/>
+                </a:solidFill>
+                <a:latin typeface="Arial" pitchFamily="34" charset="0"/>
+                <a:ea typeface="Arial" pitchFamily="34" charset="-122"/>
+                <a:cs typeface="Arial" pitchFamily="34" charset="-120"/>
+              </a:rPr>
+              <a:t>单票人工传递</a:t>
+            </a:r>
+            <a:endParaRPr lang="en-US" sz="1300" dirty="0"/>
+          </a:p>
+        </p:txBody>
       </p:sp>
       <p:sp>
         <p:nvSpPr>
@@ -2515,20 +2574,29 @@
           <p:nvPr/>
         </p:nvSpPr>
         <p:spPr>
-          <a:xfrm flipV="1">
-            <a:off x="6437376" y="1042416"/>
-            <a:ext cx="1645920" cy="365760"/>
-          </a:xfrm>
-          <a:prstGeom prst="line">
-            <a:avLst/>
-          </a:prstGeom>
-          <a:noFill/>
-          <a:ln w="9525">
-            <a:solidFill>
-              <a:srgbClr val="E5E5EA"/>
-            </a:solidFill>
-            <a:prstDash val="solid"/>
-          </a:ln>
+          <a:xfrm>
+            <a:off x="2743200" y="1371600"/>
+            <a:ext cx="1874520" cy="2194560"/>
+          </a:xfrm>
+          <a:prstGeom prst="rect">
+            <a:avLst/>
+          </a:prstGeom>
+          <a:solidFill>
+            <a:srgbClr val="FFFFFF"/>
+          </a:solidFill>
+          <a:ln w="12700">
+            <a:solidFill>
+              <a:srgbClr val="FFFFFF"/>
+            </a:solidFill>
+            <a:prstDash val="solid"/>
+          </a:ln>
+          <a:effectLst>
+            <a:outerShdw sx="100000" sy="100000" kx="0" ky="0" algn="bl" rotWithShape="0" blurRad="228600" dist="50800" dir="8100000">
+              <a:srgbClr val="000000">
+                <a:alpha val="6000"/>
+              </a:srgbClr>
+            </a:outerShdw>
+          </a:effectLst>
         </p:spPr>
       </p:sp>
       <p:sp>
@@ -2539,68 +2607,100 @@
         </p:nvSpPr>
         <p:spPr>
           <a:xfrm>
-            <a:off x="1408176" y="3511296"/>
-            <a:ext cx="1188720" cy="365760"/>
-          </a:xfrm>
-          <a:prstGeom prst="line">
-            <a:avLst/>
-          </a:prstGeom>
-          <a:noFill/>
-          <a:ln w="9525">
-            <a:solidFill>
-              <a:srgbClr val="E5E5EA"/>
-            </a:solidFill>
-            <a:prstDash val="solid"/>
-          </a:ln>
-        </p:spPr>
-      </p:sp>
-      <p:sp>
-        <p:nvSpPr>
-          <p:cNvPr id="9" name="Shape 7"/>
-          <p:cNvSpPr/>
-          <p:nvPr/>
-        </p:nvSpPr>
-        <p:spPr>
-          <a:xfrm>
-            <a:off x="6894576" y="3602736"/>
-            <a:ext cx="1005840" cy="365760"/>
-          </a:xfrm>
-          <a:prstGeom prst="line">
-            <a:avLst/>
-          </a:prstGeom>
-          <a:noFill/>
-          <a:ln w="9525">
-            <a:solidFill>
-              <a:srgbClr val="E5E5EA"/>
-            </a:solidFill>
-            <a:prstDash val="solid"/>
-          </a:ln>
-        </p:spPr>
-      </p:sp>
-      <p:sp>
-        <p:nvSpPr>
-          <p:cNvPr id="10" name="Shape 8"/>
-          <p:cNvSpPr/>
-          <p:nvPr/>
-        </p:nvSpPr>
-        <p:spPr>
-          <a:xfrm>
-            <a:off x="914400" y="1463040"/>
-            <a:ext cx="82296" cy="82296"/>
-          </a:xfrm>
-          <a:prstGeom prst="rect">
-            <a:avLst/>
-          </a:prstGeom>
-          <a:solidFill>
-            <a:srgbClr val="8E8E93"/>
-          </a:solidFill>
-          <a:ln w="12700">
-            <a:solidFill>
-              <a:srgbClr val="8E8E93"/>
-            </a:solidFill>
-            <a:prstDash val="solid"/>
-          </a:ln>
-        </p:spPr>
+            <a:off x="2907792" y="1600200"/>
+            <a:ext cx="109728" cy="109728"/>
+          </a:xfrm>
+          <a:prstGeom prst="rect">
+            <a:avLst/>
+          </a:prstGeom>
+          <a:solidFill>
+            <a:srgbClr val="C7C7CC"/>
+          </a:solidFill>
+          <a:ln w="12700">
+            <a:solidFill>
+              <a:srgbClr val="C7C7CC"/>
+            </a:solidFill>
+            <a:prstDash val="solid"/>
+          </a:ln>
+        </p:spPr>
+      </p:sp>
+      <p:sp>
+        <p:nvSpPr>
+          <p:cNvPr id="9" name="Text 7"/>
+          <p:cNvSpPr/>
+          <p:nvPr/>
+        </p:nvSpPr>
+        <p:spPr>
+          <a:xfrm>
+            <a:off x="2907792" y="1965960"/>
+            <a:ext cx="1554480" cy="457200"/>
+          </a:xfrm>
+          <a:prstGeom prst="rect">
+            <a:avLst/>
+          </a:prstGeom>
+          <a:noFill/>
+          <a:ln/>
+        </p:spPr>
+        <p:txBody>
+          <a:bodyPr wrap="square" lIns="0" tIns="0" rIns="0" bIns="0" rtlCol="0" anchor="ctr"/>
+          <a:lstStyle/>
+          <a:p>
+            <a:pPr indent="0" marL="0">
+              <a:buNone/>
+            </a:pPr>
+            <a:r>
+              <a:rPr lang="en-US" sz="2000" b="1" dirty="0">
+                <a:solidFill>
+                  <a:srgbClr val="111111"/>
+                </a:solidFill>
+                <a:latin typeface="Arial" pitchFamily="34" charset="0"/>
+                <a:ea typeface="Arial" pitchFamily="34" charset="-122"/>
+                <a:cs typeface="Arial" pitchFamily="34" charset="-120"/>
+              </a:rPr>
+              <a:t>易漏检</a:t>
+            </a:r>
+            <a:endParaRPr lang="en-US" sz="2000" dirty="0"/>
+          </a:p>
+        </p:txBody>
+      </p:sp>
+      <p:sp>
+        <p:nvSpPr>
+          <p:cNvPr id="10" name="Text 8"/>
+          <p:cNvSpPr/>
+          <p:nvPr/>
+        </p:nvSpPr>
+        <p:spPr>
+          <a:xfrm>
+            <a:off x="2907792" y="2514600"/>
+            <a:ext cx="1554480" cy="731520"/>
+          </a:xfrm>
+          <a:prstGeom prst="rect">
+            <a:avLst/>
+          </a:prstGeom>
+          <a:noFill/>
+          <a:ln/>
+        </p:spPr>
+        <p:txBody>
+          <a:bodyPr wrap="square" lIns="0" tIns="0" rIns="0" bIns="0" rtlCol="0" anchor="ctr"/>
+          <a:lstStyle/>
+          <a:p>
+            <a:pPr indent="0" marL="0">
+              <a:buNone/>
+            </a:pPr>
+            <a:r>
+              <a:rPr lang="en-US" sz="1300" dirty="0">
+                <a:solidFill>
+                  <a:srgbClr val="8E8E93"/>
+                </a:solidFill>
+                <a:latin typeface="Arial" pitchFamily="34" charset="0"/>
+                <a:ea typeface="Arial" pitchFamily="34" charset="-122"/>
+                <a:cs typeface="Arial" pitchFamily="34" charset="-120"/>
+              </a:rPr>
+              <a:t>25 项措施 × 5 列确认</a:t>
+            </a:r>
+            <a:endParaRPr lang="en-US" sz="1300" dirty="0"/>
+          </a:p>
+        </p:txBody>
       </p:sp>
       <p:sp>
         <p:nvSpPr>
@@ -2610,8 +2710,40 @@
         </p:nvSpPr>
         <p:spPr>
           <a:xfrm>
-            <a:off x="2011680" y="1097280"/>
-            <a:ext cx="64008" cy="64008"/>
+            <a:off x="4846320" y="1371600"/>
+            <a:ext cx="1874520" cy="2194560"/>
+          </a:xfrm>
+          <a:prstGeom prst="rect">
+            <a:avLst/>
+          </a:prstGeom>
+          <a:solidFill>
+            <a:srgbClr val="FFFFFF"/>
+          </a:solidFill>
+          <a:ln w="12700">
+            <a:solidFill>
+              <a:srgbClr val="FFFFFF"/>
+            </a:solidFill>
+            <a:prstDash val="solid"/>
+          </a:ln>
+          <a:effectLst>
+            <a:outerShdw sx="100000" sy="100000" kx="0" ky="0" algn="bl" rotWithShape="0" blurRad="228600" dist="50800" dir="8100000">
+              <a:srgbClr val="000000">
+                <a:alpha val="6000"/>
+              </a:srgbClr>
+            </a:outerShdw>
+          </a:effectLst>
+        </p:spPr>
+      </p:sp>
+      <p:sp>
+        <p:nvSpPr>
+          <p:cNvPr id="12" name="Shape 10"/>
+          <p:cNvSpPr/>
+          <p:nvPr/>
+        </p:nvSpPr>
+        <p:spPr>
+          <a:xfrm>
+            <a:off x="5010912" y="1600200"/>
+            <a:ext cx="109728" cy="109728"/>
           </a:xfrm>
           <a:prstGeom prst="rect">
             <a:avLst/>
@@ -2629,64 +2761,141 @@
       </p:sp>
       <p:sp>
         <p:nvSpPr>
-          <p:cNvPr id="12" name="Shape 10"/>
-          <p:cNvSpPr/>
-          <p:nvPr/>
-        </p:nvSpPr>
-        <p:spPr>
-          <a:xfrm>
-            <a:off x="2743200" y="1828800"/>
-            <a:ext cx="54864" cy="54864"/>
-          </a:xfrm>
-          <a:prstGeom prst="rect">
-            <a:avLst/>
-          </a:prstGeom>
-          <a:solidFill>
-            <a:srgbClr val="AEAEB2"/>
-          </a:solidFill>
-          <a:ln w="12700">
-            <a:solidFill>
-              <a:srgbClr val="AEAEB2"/>
-            </a:solidFill>
-            <a:prstDash val="solid"/>
-          </a:ln>
-        </p:spPr>
-      </p:sp>
-      <p:sp>
-        <p:nvSpPr>
-          <p:cNvPr id="13" name="Shape 11"/>
-          <p:cNvSpPr/>
-          <p:nvPr/>
-        </p:nvSpPr>
-        <p:spPr>
-          <a:xfrm>
-            <a:off x="6400800" y="1371600"/>
-            <a:ext cx="73152" cy="73152"/>
-          </a:xfrm>
-          <a:prstGeom prst="rect">
-            <a:avLst/>
-          </a:prstGeom>
-          <a:solidFill>
-            <a:srgbClr val="8E8E93"/>
-          </a:solidFill>
-          <a:ln w="12700">
-            <a:solidFill>
-              <a:srgbClr val="8E8E93"/>
-            </a:solidFill>
-            <a:prstDash val="solid"/>
-          </a:ln>
-        </p:spPr>
-      </p:sp>
-      <p:sp>
-        <p:nvSpPr>
-          <p:cNvPr id="14" name="Shape 12"/>
-          <p:cNvSpPr/>
-          <p:nvPr/>
-        </p:nvSpPr>
-        <p:spPr>
-          <a:xfrm>
-            <a:off x="7406640" y="1737360"/>
-            <a:ext cx="54864" cy="54864"/>
+          <p:cNvPr id="13" name="Text 11"/>
+          <p:cNvSpPr/>
+          <p:nvPr/>
+        </p:nvSpPr>
+        <p:spPr>
+          <a:xfrm>
+            <a:off x="5010912" y="1965960"/>
+            <a:ext cx="1554480" cy="457200"/>
+          </a:xfrm>
+          <a:prstGeom prst="rect">
+            <a:avLst/>
+          </a:prstGeom>
+          <a:noFill/>
+          <a:ln/>
+        </p:spPr>
+        <p:txBody>
+          <a:bodyPr wrap="square" lIns="0" tIns="0" rIns="0" bIns="0" rtlCol="0" anchor="ctr"/>
+          <a:lstStyle/>
+          <a:p>
+            <a:pPr indent="0" marL="0">
+              <a:buNone/>
+            </a:pPr>
+            <a:r>
+              <a:rPr lang="en-US" sz="2000" b="1" dirty="0">
+                <a:solidFill>
+                  <a:srgbClr val="111111"/>
+                </a:solidFill>
+                <a:latin typeface="Arial" pitchFamily="34" charset="0"/>
+                <a:ea typeface="Arial" pitchFamily="34" charset="-122"/>
+                <a:cs typeface="Arial" pitchFamily="34" charset="-120"/>
+              </a:rPr>
+              <a:t>人工审核</a:t>
+            </a:r>
+            <a:endParaRPr lang="en-US" sz="2000" dirty="0"/>
+          </a:p>
+        </p:txBody>
+      </p:sp>
+      <p:sp>
+        <p:nvSpPr>
+          <p:cNvPr id="14" name="Text 12"/>
+          <p:cNvSpPr/>
+          <p:nvPr/>
+        </p:nvSpPr>
+        <p:spPr>
+          <a:xfrm>
+            <a:off x="5010912" y="2514600"/>
+            <a:ext cx="1554480" cy="731520"/>
+          </a:xfrm>
+          <a:prstGeom prst="rect">
+            <a:avLst/>
+          </a:prstGeom>
+          <a:noFill/>
+          <a:ln/>
+        </p:spPr>
+        <p:txBody>
+          <a:bodyPr wrap="square" lIns="0" tIns="0" rIns="0" bIns="0" rtlCol="0" anchor="ctr"/>
+          <a:lstStyle/>
+          <a:p>
+            <a:pPr indent="0" marL="0">
+              <a:buNone/>
+            </a:pPr>
+            <a:r>
+              <a:rPr lang="en-US" sz="1300" dirty="0">
+                <a:solidFill>
+                  <a:srgbClr val="8E8E93"/>
+                </a:solidFill>
+                <a:latin typeface="Arial" pitchFamily="34" charset="0"/>
+                <a:ea typeface="Arial" pitchFamily="34" charset="-122"/>
+                <a:cs typeface="Arial" pitchFamily="34" charset="-120"/>
+              </a:rPr>
+              <a:t>审批凭人工经验，</a:t>
+            </a:r>
+            <a:endParaRPr lang="en-US" sz="1300" dirty="0"/>
+          </a:p>
+          <a:p>
+            <a:pPr indent="0" marL="0">
+              <a:buNone/>
+            </a:pPr>
+            <a:r>
+              <a:rPr lang="en-US" sz="1300" dirty="0">
+                <a:solidFill>
+                  <a:srgbClr val="8E8E93"/>
+                </a:solidFill>
+                <a:latin typeface="Arial" pitchFamily="34" charset="0"/>
+                <a:ea typeface="Arial" pitchFamily="34" charset="-122"/>
+                <a:cs typeface="Arial" pitchFamily="34" charset="-120"/>
+              </a:rPr>
+              <a:t>自动化审核更规范</a:t>
+            </a:r>
+            <a:endParaRPr lang="en-US" sz="1300" dirty="0"/>
+          </a:p>
+        </p:txBody>
+      </p:sp>
+      <p:sp>
+        <p:nvSpPr>
+          <p:cNvPr id="15" name="Shape 13"/>
+          <p:cNvSpPr/>
+          <p:nvPr/>
+        </p:nvSpPr>
+        <p:spPr>
+          <a:xfrm>
+            <a:off x="6949440" y="1371600"/>
+            <a:ext cx="1874520" cy="2194560"/>
+          </a:xfrm>
+          <a:prstGeom prst="rect">
+            <a:avLst/>
+          </a:prstGeom>
+          <a:solidFill>
+            <a:srgbClr val="FFFFFF"/>
+          </a:solidFill>
+          <a:ln w="12700">
+            <a:solidFill>
+              <a:srgbClr val="FFFFFF"/>
+            </a:solidFill>
+            <a:prstDash val="solid"/>
+          </a:ln>
+          <a:effectLst>
+            <a:outerShdw sx="100000" sy="100000" kx="0" ky="0" algn="bl" rotWithShape="0" blurRad="228600" dist="50800" dir="8100000">
+              <a:srgbClr val="000000">
+                <a:alpha val="6000"/>
+              </a:srgbClr>
+            </a:outerShdw>
+          </a:effectLst>
+        </p:spPr>
+      </p:sp>
+      <p:sp>
+        <p:nvSpPr>
+          <p:cNvPr id="16" name="Shape 14"/>
+          <p:cNvSpPr/>
+          <p:nvPr/>
+        </p:nvSpPr>
+        <p:spPr>
+          <a:xfrm>
+            <a:off x="7114032" y="1600200"/>
+            <a:ext cx="109728" cy="109728"/>
           </a:xfrm>
           <a:prstGeom prst="rect">
             <a:avLst/>
@@ -2704,139 +2913,14 @@
       </p:sp>
       <p:sp>
         <p:nvSpPr>
-          <p:cNvPr id="15" name="Shape 13"/>
-          <p:cNvSpPr/>
-          <p:nvPr/>
-        </p:nvSpPr>
-        <p:spPr>
-          <a:xfrm>
-            <a:off x="8046720" y="1005840"/>
-            <a:ext cx="64008" cy="64008"/>
-          </a:xfrm>
-          <a:prstGeom prst="rect">
-            <a:avLst/>
-          </a:prstGeom>
-          <a:solidFill>
-            <a:srgbClr val="AEAEB2"/>
-          </a:solidFill>
-          <a:ln w="12700">
-            <a:solidFill>
-              <a:srgbClr val="AEAEB2"/>
-            </a:solidFill>
-            <a:prstDash val="solid"/>
-          </a:ln>
-        </p:spPr>
-      </p:sp>
-      <p:sp>
-        <p:nvSpPr>
-          <p:cNvPr id="16" name="Shape 14"/>
-          <p:cNvSpPr/>
-          <p:nvPr/>
-        </p:nvSpPr>
-        <p:spPr>
-          <a:xfrm>
-            <a:off x="1371600" y="3474720"/>
-            <a:ext cx="64008" cy="64008"/>
-          </a:xfrm>
-          <a:prstGeom prst="rect">
-            <a:avLst/>
-          </a:prstGeom>
-          <a:solidFill>
-            <a:srgbClr val="C7C7CC"/>
-          </a:solidFill>
-          <a:ln w="12700">
-            <a:solidFill>
-              <a:srgbClr val="C7C7CC"/>
-            </a:solidFill>
-            <a:prstDash val="solid"/>
-          </a:ln>
-        </p:spPr>
-      </p:sp>
-      <p:sp>
-        <p:nvSpPr>
-          <p:cNvPr id="17" name="Shape 15"/>
-          <p:cNvSpPr/>
-          <p:nvPr/>
-        </p:nvSpPr>
-        <p:spPr>
-          <a:xfrm>
-            <a:off x="2560320" y="3840480"/>
-            <a:ext cx="45720" cy="45720"/>
-          </a:xfrm>
-          <a:prstGeom prst="rect">
-            <a:avLst/>
-          </a:prstGeom>
-          <a:solidFill>
-            <a:srgbClr val="D1D1D6"/>
-          </a:solidFill>
-          <a:ln w="12700">
-            <a:solidFill>
-              <a:srgbClr val="D1D1D6"/>
-            </a:solidFill>
-            <a:prstDash val="solid"/>
-          </a:ln>
-        </p:spPr>
-      </p:sp>
-      <p:sp>
-        <p:nvSpPr>
-          <p:cNvPr id="18" name="Shape 16"/>
-          <p:cNvSpPr/>
-          <p:nvPr/>
-        </p:nvSpPr>
-        <p:spPr>
-          <a:xfrm>
-            <a:off x="6858000" y="3566160"/>
-            <a:ext cx="73152" cy="73152"/>
-          </a:xfrm>
-          <a:prstGeom prst="rect">
-            <a:avLst/>
-          </a:prstGeom>
-          <a:solidFill>
-            <a:srgbClr val="8E8E93"/>
-          </a:solidFill>
-          <a:ln w="12700">
-            <a:solidFill>
-              <a:srgbClr val="8E8E93"/>
-            </a:solidFill>
-            <a:prstDash val="solid"/>
-          </a:ln>
-        </p:spPr>
-      </p:sp>
-      <p:sp>
-        <p:nvSpPr>
-          <p:cNvPr id="19" name="Shape 17"/>
-          <p:cNvSpPr/>
-          <p:nvPr/>
-        </p:nvSpPr>
-        <p:spPr>
-          <a:xfrm>
-            <a:off x="7863840" y="3931920"/>
-            <a:ext cx="54864" cy="54864"/>
-          </a:xfrm>
-          <a:prstGeom prst="rect">
-            <a:avLst/>
-          </a:prstGeom>
-          <a:solidFill>
-            <a:srgbClr val="C7C7CC"/>
-          </a:solidFill>
-          <a:ln w="12700">
-            <a:solidFill>
-              <a:srgbClr val="C7C7CC"/>
-            </a:solidFill>
-            <a:prstDash val="solid"/>
-          </a:ln>
-        </p:spPr>
-      </p:sp>
-      <p:sp>
-        <p:nvSpPr>
-          <p:cNvPr id="20" name="Text 18"/>
-          <p:cNvSpPr/>
-          <p:nvPr/>
-        </p:nvSpPr>
-        <p:spPr>
-          <a:xfrm>
-            <a:off x="731520" y="2057400"/>
-            <a:ext cx="7680960" cy="411480"/>
+          <p:cNvPr id="17" name="Text 15"/>
+          <p:cNvSpPr/>
+          <p:nvPr/>
+        </p:nvSpPr>
+        <p:spPr>
+          <a:xfrm>
+            <a:off x="7114032" y="1965960"/>
+            <a:ext cx="1554480" cy="457200"/>
           </a:xfrm>
           <a:prstGeom prst="rect">
             <a:avLst/>
@@ -2848,11 +2932,11 @@
           <a:bodyPr wrap="square" lIns="0" tIns="0" rIns="0" bIns="0" rtlCol="0" anchor="ctr"/>
           <a:lstStyle/>
           <a:p>
-            <a:pPr algn="ctr" indent="0" marL="0">
-              <a:buNone/>
-            </a:pPr>
-            <a:r>
-              <a:rPr lang="en-US" sz="2800" b="1" dirty="0">
+            <a:pPr indent="0" marL="0">
+              <a:buNone/>
+            </a:pPr>
+            <a:r>
+              <a:rPr lang="en-US" sz="2000" b="1" dirty="0">
                 <a:solidFill>
                   <a:srgbClr val="111111"/>
                 </a:solidFill>
@@ -2860,22 +2944,22 @@
                 <a:ea typeface="Arial" pitchFamily="34" charset="-122"/>
                 <a:cs typeface="Arial" pitchFamily="34" charset="-120"/>
               </a:rPr>
-              <a:t>拍照一张带气作业票</a:t>
-            </a:r>
-            <a:endParaRPr lang="en-US" sz="2800" dirty="0"/>
-          </a:p>
-        </p:txBody>
-      </p:sp>
-      <p:sp>
-        <p:nvSpPr>
-          <p:cNvPr id="21" name="Text 19"/>
-          <p:cNvSpPr/>
-          <p:nvPr/>
-        </p:nvSpPr>
-        <p:spPr>
-          <a:xfrm>
-            <a:off x="731520" y="2606040"/>
-            <a:ext cx="7680960" cy="365760"/>
+              <a:t>数据沉睡</a:t>
+            </a:r>
+            <a:endParaRPr lang="en-US" sz="2000" dirty="0"/>
+          </a:p>
+        </p:txBody>
+      </p:sp>
+      <p:sp>
+        <p:nvSpPr>
+          <p:cNvPr id="18" name="Text 16"/>
+          <p:cNvSpPr/>
+          <p:nvPr/>
+        </p:nvSpPr>
+        <p:spPr>
+          <a:xfrm>
+            <a:off x="7114032" y="2514600"/>
+            <a:ext cx="1554480" cy="731520"/>
           </a:xfrm>
           <a:prstGeom prst="rect">
             <a:avLst/>
@@ -2887,21 +2971,21 @@
           <a:bodyPr wrap="square" lIns="0" tIns="0" rIns="0" bIns="0" rtlCol="0" anchor="ctr"/>
           <a:lstStyle/>
           <a:p>
-            <a:pPr algn="ctr" indent="0" marL="0">
-              <a:buNone/>
-            </a:pPr>
-            <a:r>
-              <a:rPr lang="en-US" sz="2200" dirty="0">
-                <a:solidFill>
-                  <a:srgbClr val="3A3A3C"/>
-                </a:solidFill>
-                <a:latin typeface="Arial" pitchFamily="34" charset="0"/>
-                <a:ea typeface="Arial" pitchFamily="34" charset="-122"/>
-                <a:cs typeface="Arial" pitchFamily="34" charset="-120"/>
-              </a:rPr>
-              <a:t>15 秒完成识别 · 校验 · 审批建议</a:t>
-            </a:r>
-            <a:endParaRPr lang="en-US" sz="2200" dirty="0"/>
+            <a:pPr indent="0" marL="0">
+              <a:buNone/>
+            </a:pPr>
+            <a:r>
+              <a:rPr lang="en-US" sz="1300" dirty="0">
+                <a:solidFill>
+                  <a:srgbClr val="8E8E93"/>
+                </a:solidFill>
+                <a:latin typeface="Arial" pitchFamily="34" charset="0"/>
+                <a:ea typeface="Arial" pitchFamily="34" charset="-122"/>
+                <a:cs typeface="Arial" pitchFamily="34" charset="-120"/>
+              </a:rPr>
+              <a:t>纸质归档，无法统计问题</a:t>
+            </a:r>
+            <a:endParaRPr lang="en-US" sz="1300" dirty="0"/>
           </a:p>
         </p:txBody>
       </p:sp>
@@ -2942,14 +3026,448 @@
       </p:grpSpPr>
       <p:sp>
         <p:nvSpPr>
-          <p:cNvPr id="2" name="Text 0"/>
-          <p:cNvSpPr/>
-          <p:nvPr/>
-        </p:nvSpPr>
-        <p:spPr>
-          <a:xfrm>
-            <a:off x="640080" y="502920"/>
-            <a:ext cx="7772400" cy="411480"/>
+          <p:cNvPr id="2" name="Shape 0"/>
+          <p:cNvSpPr/>
+          <p:nvPr/>
+        </p:nvSpPr>
+        <p:spPr>
+          <a:xfrm flipV="1">
+            <a:off x="950976" y="1133856"/>
+            <a:ext cx="1097280" cy="365760"/>
+          </a:xfrm>
+          <a:prstGeom prst="line">
+            <a:avLst/>
+          </a:prstGeom>
+          <a:noFill/>
+          <a:ln w="9525">
+            <a:solidFill>
+              <a:srgbClr val="E5E5EA"/>
+            </a:solidFill>
+            <a:prstDash val="solid"/>
+          </a:ln>
+        </p:spPr>
+      </p:sp>
+      <p:sp>
+        <p:nvSpPr>
+          <p:cNvPr id="3" name="Shape 1"/>
+          <p:cNvSpPr/>
+          <p:nvPr/>
+        </p:nvSpPr>
+        <p:spPr>
+          <a:xfrm>
+            <a:off x="2048256" y="1133856"/>
+            <a:ext cx="731520" cy="731520"/>
+          </a:xfrm>
+          <a:prstGeom prst="line">
+            <a:avLst/>
+          </a:prstGeom>
+          <a:noFill/>
+          <a:ln w="9525">
+            <a:solidFill>
+              <a:srgbClr val="E5E5EA"/>
+            </a:solidFill>
+            <a:prstDash val="solid"/>
+          </a:ln>
+        </p:spPr>
+      </p:sp>
+      <p:sp>
+        <p:nvSpPr>
+          <p:cNvPr id="4" name="Shape 2"/>
+          <p:cNvSpPr/>
+          <p:nvPr/>
+        </p:nvSpPr>
+        <p:spPr>
+          <a:xfrm>
+            <a:off x="950976" y="1499616"/>
+            <a:ext cx="1828800" cy="365760"/>
+          </a:xfrm>
+          <a:prstGeom prst="line">
+            <a:avLst/>
+          </a:prstGeom>
+          <a:noFill/>
+          <a:ln w="9525">
+            <a:solidFill>
+              <a:srgbClr val="E5E5EA"/>
+            </a:solidFill>
+            <a:prstDash val="solid"/>
+          </a:ln>
+        </p:spPr>
+      </p:sp>
+      <p:sp>
+        <p:nvSpPr>
+          <p:cNvPr id="5" name="Shape 3"/>
+          <p:cNvSpPr/>
+          <p:nvPr/>
+        </p:nvSpPr>
+        <p:spPr>
+          <a:xfrm>
+            <a:off x="6437376" y="1408176"/>
+            <a:ext cx="1005840" cy="365760"/>
+          </a:xfrm>
+          <a:prstGeom prst="line">
+            <a:avLst/>
+          </a:prstGeom>
+          <a:noFill/>
+          <a:ln w="9525">
+            <a:solidFill>
+              <a:srgbClr val="E5E5EA"/>
+            </a:solidFill>
+            <a:prstDash val="solid"/>
+          </a:ln>
+        </p:spPr>
+      </p:sp>
+      <p:sp>
+        <p:nvSpPr>
+          <p:cNvPr id="6" name="Shape 4"/>
+          <p:cNvSpPr/>
+          <p:nvPr/>
+        </p:nvSpPr>
+        <p:spPr>
+          <a:xfrm flipV="1">
+            <a:off x="7443216" y="1042416"/>
+            <a:ext cx="640080" cy="731520"/>
+          </a:xfrm>
+          <a:prstGeom prst="line">
+            <a:avLst/>
+          </a:prstGeom>
+          <a:noFill/>
+          <a:ln w="9525">
+            <a:solidFill>
+              <a:srgbClr val="E5E5EA"/>
+            </a:solidFill>
+            <a:prstDash val="solid"/>
+          </a:ln>
+        </p:spPr>
+      </p:sp>
+      <p:sp>
+        <p:nvSpPr>
+          <p:cNvPr id="7" name="Shape 5"/>
+          <p:cNvSpPr/>
+          <p:nvPr/>
+        </p:nvSpPr>
+        <p:spPr>
+          <a:xfrm flipV="1">
+            <a:off x="6437376" y="1042416"/>
+            <a:ext cx="1645920" cy="365760"/>
+          </a:xfrm>
+          <a:prstGeom prst="line">
+            <a:avLst/>
+          </a:prstGeom>
+          <a:noFill/>
+          <a:ln w="9525">
+            <a:solidFill>
+              <a:srgbClr val="E5E5EA"/>
+            </a:solidFill>
+            <a:prstDash val="solid"/>
+          </a:ln>
+        </p:spPr>
+      </p:sp>
+      <p:sp>
+        <p:nvSpPr>
+          <p:cNvPr id="8" name="Shape 6"/>
+          <p:cNvSpPr/>
+          <p:nvPr/>
+        </p:nvSpPr>
+        <p:spPr>
+          <a:xfrm>
+            <a:off x="1408176" y="3511296"/>
+            <a:ext cx="1188720" cy="365760"/>
+          </a:xfrm>
+          <a:prstGeom prst="line">
+            <a:avLst/>
+          </a:prstGeom>
+          <a:noFill/>
+          <a:ln w="9525">
+            <a:solidFill>
+              <a:srgbClr val="E5E5EA"/>
+            </a:solidFill>
+            <a:prstDash val="solid"/>
+          </a:ln>
+        </p:spPr>
+      </p:sp>
+      <p:sp>
+        <p:nvSpPr>
+          <p:cNvPr id="9" name="Shape 7"/>
+          <p:cNvSpPr/>
+          <p:nvPr/>
+        </p:nvSpPr>
+        <p:spPr>
+          <a:xfrm>
+            <a:off x="6894576" y="3602736"/>
+            <a:ext cx="1005840" cy="365760"/>
+          </a:xfrm>
+          <a:prstGeom prst="line">
+            <a:avLst/>
+          </a:prstGeom>
+          <a:noFill/>
+          <a:ln w="9525">
+            <a:solidFill>
+              <a:srgbClr val="E5E5EA"/>
+            </a:solidFill>
+            <a:prstDash val="solid"/>
+          </a:ln>
+        </p:spPr>
+      </p:sp>
+      <p:sp>
+        <p:nvSpPr>
+          <p:cNvPr id="10" name="Shape 8"/>
+          <p:cNvSpPr/>
+          <p:nvPr/>
+        </p:nvSpPr>
+        <p:spPr>
+          <a:xfrm>
+            <a:off x="914400" y="1463040"/>
+            <a:ext cx="82296" cy="82296"/>
+          </a:xfrm>
+          <a:prstGeom prst="rect">
+            <a:avLst/>
+          </a:prstGeom>
+          <a:solidFill>
+            <a:srgbClr val="8E8E93"/>
+          </a:solidFill>
+          <a:ln w="12700">
+            <a:solidFill>
+              <a:srgbClr val="8E8E93"/>
+            </a:solidFill>
+            <a:prstDash val="solid"/>
+          </a:ln>
+        </p:spPr>
+      </p:sp>
+      <p:sp>
+        <p:nvSpPr>
+          <p:cNvPr id="11" name="Shape 9"/>
+          <p:cNvSpPr/>
+          <p:nvPr/>
+        </p:nvSpPr>
+        <p:spPr>
+          <a:xfrm>
+            <a:off x="2011680" y="1097280"/>
+            <a:ext cx="64008" cy="64008"/>
+          </a:xfrm>
+          <a:prstGeom prst="rect">
+            <a:avLst/>
+          </a:prstGeom>
+          <a:solidFill>
+            <a:srgbClr val="C7C7CC"/>
+          </a:solidFill>
+          <a:ln w="12700">
+            <a:solidFill>
+              <a:srgbClr val="C7C7CC"/>
+            </a:solidFill>
+            <a:prstDash val="solid"/>
+          </a:ln>
+        </p:spPr>
+      </p:sp>
+      <p:sp>
+        <p:nvSpPr>
+          <p:cNvPr id="12" name="Shape 10"/>
+          <p:cNvSpPr/>
+          <p:nvPr/>
+        </p:nvSpPr>
+        <p:spPr>
+          <a:xfrm>
+            <a:off x="2743200" y="1828800"/>
+            <a:ext cx="54864" cy="54864"/>
+          </a:xfrm>
+          <a:prstGeom prst="rect">
+            <a:avLst/>
+          </a:prstGeom>
+          <a:solidFill>
+            <a:srgbClr val="AEAEB2"/>
+          </a:solidFill>
+          <a:ln w="12700">
+            <a:solidFill>
+              <a:srgbClr val="AEAEB2"/>
+            </a:solidFill>
+            <a:prstDash val="solid"/>
+          </a:ln>
+        </p:spPr>
+      </p:sp>
+      <p:sp>
+        <p:nvSpPr>
+          <p:cNvPr id="13" name="Shape 11"/>
+          <p:cNvSpPr/>
+          <p:nvPr/>
+        </p:nvSpPr>
+        <p:spPr>
+          <a:xfrm>
+            <a:off x="6400800" y="1371600"/>
+            <a:ext cx="73152" cy="73152"/>
+          </a:xfrm>
+          <a:prstGeom prst="rect">
+            <a:avLst/>
+          </a:prstGeom>
+          <a:solidFill>
+            <a:srgbClr val="8E8E93"/>
+          </a:solidFill>
+          <a:ln w="12700">
+            <a:solidFill>
+              <a:srgbClr val="8E8E93"/>
+            </a:solidFill>
+            <a:prstDash val="solid"/>
+          </a:ln>
+        </p:spPr>
+      </p:sp>
+      <p:sp>
+        <p:nvSpPr>
+          <p:cNvPr id="14" name="Shape 12"/>
+          <p:cNvSpPr/>
+          <p:nvPr/>
+        </p:nvSpPr>
+        <p:spPr>
+          <a:xfrm>
+            <a:off x="7406640" y="1737360"/>
+            <a:ext cx="54864" cy="54864"/>
+          </a:xfrm>
+          <a:prstGeom prst="rect">
+            <a:avLst/>
+          </a:prstGeom>
+          <a:solidFill>
+            <a:srgbClr val="C7C7CC"/>
+          </a:solidFill>
+          <a:ln w="12700">
+            <a:solidFill>
+              <a:srgbClr val="C7C7CC"/>
+            </a:solidFill>
+            <a:prstDash val="solid"/>
+          </a:ln>
+        </p:spPr>
+      </p:sp>
+      <p:sp>
+        <p:nvSpPr>
+          <p:cNvPr id="15" name="Shape 13"/>
+          <p:cNvSpPr/>
+          <p:nvPr/>
+        </p:nvSpPr>
+        <p:spPr>
+          <a:xfrm>
+            <a:off x="8046720" y="1005840"/>
+            <a:ext cx="64008" cy="64008"/>
+          </a:xfrm>
+          <a:prstGeom prst="rect">
+            <a:avLst/>
+          </a:prstGeom>
+          <a:solidFill>
+            <a:srgbClr val="AEAEB2"/>
+          </a:solidFill>
+          <a:ln w="12700">
+            <a:solidFill>
+              <a:srgbClr val="AEAEB2"/>
+            </a:solidFill>
+            <a:prstDash val="solid"/>
+          </a:ln>
+        </p:spPr>
+      </p:sp>
+      <p:sp>
+        <p:nvSpPr>
+          <p:cNvPr id="16" name="Shape 14"/>
+          <p:cNvSpPr/>
+          <p:nvPr/>
+        </p:nvSpPr>
+        <p:spPr>
+          <a:xfrm>
+            <a:off x="1371600" y="3474720"/>
+            <a:ext cx="64008" cy="64008"/>
+          </a:xfrm>
+          <a:prstGeom prst="rect">
+            <a:avLst/>
+          </a:prstGeom>
+          <a:solidFill>
+            <a:srgbClr val="C7C7CC"/>
+          </a:solidFill>
+          <a:ln w="12700">
+            <a:solidFill>
+              <a:srgbClr val="C7C7CC"/>
+            </a:solidFill>
+            <a:prstDash val="solid"/>
+          </a:ln>
+        </p:spPr>
+      </p:sp>
+      <p:sp>
+        <p:nvSpPr>
+          <p:cNvPr id="17" name="Shape 15"/>
+          <p:cNvSpPr/>
+          <p:nvPr/>
+        </p:nvSpPr>
+        <p:spPr>
+          <a:xfrm>
+            <a:off x="2560320" y="3840480"/>
+            <a:ext cx="45720" cy="45720"/>
+          </a:xfrm>
+          <a:prstGeom prst="rect">
+            <a:avLst/>
+          </a:prstGeom>
+          <a:solidFill>
+            <a:srgbClr val="D1D1D6"/>
+          </a:solidFill>
+          <a:ln w="12700">
+            <a:solidFill>
+              <a:srgbClr val="D1D1D6"/>
+            </a:solidFill>
+            <a:prstDash val="solid"/>
+          </a:ln>
+        </p:spPr>
+      </p:sp>
+      <p:sp>
+        <p:nvSpPr>
+          <p:cNvPr id="18" name="Shape 16"/>
+          <p:cNvSpPr/>
+          <p:nvPr/>
+        </p:nvSpPr>
+        <p:spPr>
+          <a:xfrm>
+            <a:off x="6858000" y="3566160"/>
+            <a:ext cx="73152" cy="73152"/>
+          </a:xfrm>
+          <a:prstGeom prst="rect">
+            <a:avLst/>
+          </a:prstGeom>
+          <a:solidFill>
+            <a:srgbClr val="8E8E93"/>
+          </a:solidFill>
+          <a:ln w="12700">
+            <a:solidFill>
+              <a:srgbClr val="8E8E93"/>
+            </a:solidFill>
+            <a:prstDash val="solid"/>
+          </a:ln>
+        </p:spPr>
+      </p:sp>
+      <p:sp>
+        <p:nvSpPr>
+          <p:cNvPr id="19" name="Shape 17"/>
+          <p:cNvSpPr/>
+          <p:nvPr/>
+        </p:nvSpPr>
+        <p:spPr>
+          <a:xfrm>
+            <a:off x="7863840" y="3931920"/>
+            <a:ext cx="54864" cy="54864"/>
+          </a:xfrm>
+          <a:prstGeom prst="rect">
+            <a:avLst/>
+          </a:prstGeom>
+          <a:solidFill>
+            <a:srgbClr val="C7C7CC"/>
+          </a:solidFill>
+          <a:ln w="12700">
+            <a:solidFill>
+              <a:srgbClr val="C7C7CC"/>
+            </a:solidFill>
+            <a:prstDash val="solid"/>
+          </a:ln>
+        </p:spPr>
+      </p:sp>
+      <p:sp>
+        <p:nvSpPr>
+          <p:cNvPr id="20" name="Text 18"/>
+          <p:cNvSpPr/>
+          <p:nvPr/>
+        </p:nvSpPr>
+        <p:spPr>
+          <a:xfrm>
+            <a:off x="731520" y="2057400"/>
+            <a:ext cx="7680960" cy="411480"/>
           </a:xfrm>
           <a:prstGeom prst="rect">
             <a:avLst/>
@@ -2961,7 +3479,7 @@
           <a:bodyPr wrap="square" lIns="0" tIns="0" rIns="0" bIns="0" rtlCol="0" anchor="ctr"/>
           <a:lstStyle/>
           <a:p>
-            <a:pPr indent="0" marL="0">
+            <a:pPr algn="ctr" indent="0" marL="0">
               <a:buNone/>
             </a:pPr>
             <a:r>
@@ -2973,7 +3491,7 @@
                 <a:ea typeface="Arial" pitchFamily="34" charset="-122"/>
                 <a:cs typeface="Arial" pitchFamily="34" charset="-120"/>
               </a:rPr>
-              <a:t>一线痛点。</a:t>
+              <a:t>拍照一张带气作业票</a:t>
             </a:r>
             <a:endParaRPr lang="en-US" sz="2800" dirty="0"/>
           </a:p>
@@ -2981,71 +3499,14 @@
       </p:sp>
       <p:sp>
         <p:nvSpPr>
-          <p:cNvPr id="3" name="Shape 1"/>
-          <p:cNvSpPr/>
-          <p:nvPr/>
-        </p:nvSpPr>
-        <p:spPr>
-          <a:xfrm>
-            <a:off x="640080" y="1371600"/>
-            <a:ext cx="1874520" cy="2194560"/>
-          </a:xfrm>
-          <a:prstGeom prst="rect">
-            <a:avLst/>
-          </a:prstGeom>
-          <a:solidFill>
-            <a:srgbClr val="FFFFFF"/>
-          </a:solidFill>
-          <a:ln w="12700">
-            <a:solidFill>
-              <a:srgbClr val="FFFFFF"/>
-            </a:solidFill>
-            <a:prstDash val="solid"/>
-          </a:ln>
-          <a:effectLst>
-            <a:outerShdw sx="100000" sy="100000" kx="0" ky="0" algn="bl" rotWithShape="0" blurRad="228600" dist="50800" dir="8100000">
-              <a:srgbClr val="000000">
-                <a:alpha val="6000"/>
-              </a:srgbClr>
-            </a:outerShdw>
-          </a:effectLst>
-        </p:spPr>
-      </p:sp>
-      <p:sp>
-        <p:nvSpPr>
-          <p:cNvPr id="4" name="Shape 2"/>
-          <p:cNvSpPr/>
-          <p:nvPr/>
-        </p:nvSpPr>
-        <p:spPr>
-          <a:xfrm>
-            <a:off x="804672" y="1600200"/>
-            <a:ext cx="109728" cy="109728"/>
-          </a:xfrm>
-          <a:prstGeom prst="rect">
-            <a:avLst/>
-          </a:prstGeom>
-          <a:solidFill>
-            <a:srgbClr val="5B8DEF"/>
-          </a:solidFill>
-          <a:ln w="12700">
-            <a:solidFill>
-              <a:srgbClr val="5B8DEF"/>
-            </a:solidFill>
-            <a:prstDash val="solid"/>
-          </a:ln>
-        </p:spPr>
-      </p:sp>
-      <p:sp>
-        <p:nvSpPr>
-          <p:cNvPr id="5" name="Text 3"/>
-          <p:cNvSpPr/>
-          <p:nvPr/>
-        </p:nvSpPr>
-        <p:spPr>
-          <a:xfrm>
-            <a:off x="804672" y="1965960"/>
-            <a:ext cx="1554480" cy="457200"/>
+          <p:cNvPr id="21" name="Text 19"/>
+          <p:cNvSpPr/>
+          <p:nvPr/>
+        </p:nvSpPr>
+        <p:spPr>
+          <a:xfrm>
+            <a:off x="731520" y="2606040"/>
+            <a:ext cx="7680960" cy="365760"/>
           </a:xfrm>
           <a:prstGeom prst="rect">
             <a:avLst/>
@@ -3057,482 +3518,21 @@
           <a:bodyPr wrap="square" lIns="0" tIns="0" rIns="0" bIns="0" rtlCol="0" anchor="ctr"/>
           <a:lstStyle/>
           <a:p>
-            <a:pPr indent="0" marL="0">
-              <a:buNone/>
-            </a:pPr>
-            <a:r>
-              <a:rPr lang="en-US" sz="2000" b="1" dirty="0">
-                <a:solidFill>
-                  <a:srgbClr val="111111"/>
-                </a:solidFill>
-                <a:latin typeface="Arial" pitchFamily="34" charset="0"/>
-                <a:ea typeface="Arial" pitchFamily="34" charset="-122"/>
-                <a:cs typeface="Arial" pitchFamily="34" charset="-120"/>
-              </a:rPr>
-              <a:t>10 分钟</a:t>
-            </a:r>
-            <a:endParaRPr lang="en-US" sz="2000" dirty="0"/>
-          </a:p>
-        </p:txBody>
-      </p:sp>
-      <p:sp>
-        <p:nvSpPr>
-          <p:cNvPr id="6" name="Text 4"/>
-          <p:cNvSpPr/>
-          <p:nvPr/>
-        </p:nvSpPr>
-        <p:spPr>
-          <a:xfrm>
-            <a:off x="804672" y="2514600"/>
-            <a:ext cx="1554480" cy="731520"/>
-          </a:xfrm>
-          <a:prstGeom prst="rect">
-            <a:avLst/>
-          </a:prstGeom>
-          <a:noFill/>
-          <a:ln/>
-        </p:spPr>
-        <p:txBody>
-          <a:bodyPr wrap="square" lIns="0" tIns="0" rIns="0" bIns="0" rtlCol="0" anchor="ctr"/>
-          <a:lstStyle/>
-          <a:p>
-            <a:pPr indent="0" marL="0">
-              <a:buNone/>
-            </a:pPr>
-            <a:r>
-              <a:rPr lang="en-US" sz="1300" dirty="0">
-                <a:solidFill>
-                  <a:srgbClr val="8E8E93"/>
-                </a:solidFill>
-                <a:latin typeface="Arial" pitchFamily="34" charset="0"/>
-                <a:ea typeface="Arial" pitchFamily="34" charset="-122"/>
-                <a:cs typeface="Arial" pitchFamily="34" charset="-120"/>
-              </a:rPr>
-              <a:t>单票人工传递</a:t>
-            </a:r>
-            <a:endParaRPr lang="en-US" sz="1300" dirty="0"/>
-          </a:p>
-        </p:txBody>
-      </p:sp>
-      <p:sp>
-        <p:nvSpPr>
-          <p:cNvPr id="7" name="Shape 5"/>
-          <p:cNvSpPr/>
-          <p:nvPr/>
-        </p:nvSpPr>
-        <p:spPr>
-          <a:xfrm>
-            <a:off x="2743200" y="1371600"/>
-            <a:ext cx="1874520" cy="2194560"/>
-          </a:xfrm>
-          <a:prstGeom prst="rect">
-            <a:avLst/>
-          </a:prstGeom>
-          <a:solidFill>
-            <a:srgbClr val="FFFFFF"/>
-          </a:solidFill>
-          <a:ln w="12700">
-            <a:solidFill>
-              <a:srgbClr val="FFFFFF"/>
-            </a:solidFill>
-            <a:prstDash val="solid"/>
-          </a:ln>
-          <a:effectLst>
-            <a:outerShdw sx="100000" sy="100000" kx="0" ky="0" algn="bl" rotWithShape="0" blurRad="228600" dist="50800" dir="8100000">
-              <a:srgbClr val="000000">
-                <a:alpha val="6000"/>
-              </a:srgbClr>
-            </a:outerShdw>
-          </a:effectLst>
-        </p:spPr>
-      </p:sp>
-      <p:sp>
-        <p:nvSpPr>
-          <p:cNvPr id="8" name="Shape 6"/>
-          <p:cNvSpPr/>
-          <p:nvPr/>
-        </p:nvSpPr>
-        <p:spPr>
-          <a:xfrm>
-            <a:off x="2907792" y="1600200"/>
-            <a:ext cx="109728" cy="109728"/>
-          </a:xfrm>
-          <a:prstGeom prst="rect">
-            <a:avLst/>
-          </a:prstGeom>
-          <a:solidFill>
-            <a:srgbClr val="C7C7CC"/>
-          </a:solidFill>
-          <a:ln w="12700">
-            <a:solidFill>
-              <a:srgbClr val="C7C7CC"/>
-            </a:solidFill>
-            <a:prstDash val="solid"/>
-          </a:ln>
-        </p:spPr>
-      </p:sp>
-      <p:sp>
-        <p:nvSpPr>
-          <p:cNvPr id="9" name="Text 7"/>
-          <p:cNvSpPr/>
-          <p:nvPr/>
-        </p:nvSpPr>
-        <p:spPr>
-          <a:xfrm>
-            <a:off x="2907792" y="1965960"/>
-            <a:ext cx="1554480" cy="457200"/>
-          </a:xfrm>
-          <a:prstGeom prst="rect">
-            <a:avLst/>
-          </a:prstGeom>
-          <a:noFill/>
-          <a:ln/>
-        </p:spPr>
-        <p:txBody>
-          <a:bodyPr wrap="square" lIns="0" tIns="0" rIns="0" bIns="0" rtlCol="0" anchor="ctr"/>
-          <a:lstStyle/>
-          <a:p>
-            <a:pPr indent="0" marL="0">
-              <a:buNone/>
-            </a:pPr>
-            <a:r>
-              <a:rPr lang="en-US" sz="2000" b="1" dirty="0">
-                <a:solidFill>
-                  <a:srgbClr val="111111"/>
-                </a:solidFill>
-                <a:latin typeface="Arial" pitchFamily="34" charset="0"/>
-                <a:ea typeface="Arial" pitchFamily="34" charset="-122"/>
-                <a:cs typeface="Arial" pitchFamily="34" charset="-120"/>
-              </a:rPr>
-              <a:t>易漏检</a:t>
-            </a:r>
-            <a:endParaRPr lang="en-US" sz="2000" dirty="0"/>
-          </a:p>
-        </p:txBody>
-      </p:sp>
-      <p:sp>
-        <p:nvSpPr>
-          <p:cNvPr id="10" name="Text 8"/>
-          <p:cNvSpPr/>
-          <p:nvPr/>
-        </p:nvSpPr>
-        <p:spPr>
-          <a:xfrm>
-            <a:off x="2907792" y="2514600"/>
-            <a:ext cx="1554480" cy="731520"/>
-          </a:xfrm>
-          <a:prstGeom prst="rect">
-            <a:avLst/>
-          </a:prstGeom>
-          <a:noFill/>
-          <a:ln/>
-        </p:spPr>
-        <p:txBody>
-          <a:bodyPr wrap="square" lIns="0" tIns="0" rIns="0" bIns="0" rtlCol="0" anchor="ctr"/>
-          <a:lstStyle/>
-          <a:p>
-            <a:pPr indent="0" marL="0">
-              <a:buNone/>
-            </a:pPr>
-            <a:r>
-              <a:rPr lang="en-US" sz="1300" dirty="0">
-                <a:solidFill>
-                  <a:srgbClr val="8E8E93"/>
-                </a:solidFill>
-                <a:latin typeface="Arial" pitchFamily="34" charset="0"/>
-                <a:ea typeface="Arial" pitchFamily="34" charset="-122"/>
-                <a:cs typeface="Arial" pitchFamily="34" charset="-120"/>
-              </a:rPr>
-              <a:t>25 项措施 × 5 列确认</a:t>
-            </a:r>
-            <a:endParaRPr lang="en-US" sz="1300" dirty="0"/>
-          </a:p>
-        </p:txBody>
-      </p:sp>
-      <p:sp>
-        <p:nvSpPr>
-          <p:cNvPr id="11" name="Shape 9"/>
-          <p:cNvSpPr/>
-          <p:nvPr/>
-        </p:nvSpPr>
-        <p:spPr>
-          <a:xfrm>
-            <a:off x="4846320" y="1371600"/>
-            <a:ext cx="1874520" cy="2194560"/>
-          </a:xfrm>
-          <a:prstGeom prst="rect">
-            <a:avLst/>
-          </a:prstGeom>
-          <a:solidFill>
-            <a:srgbClr val="FFFFFF"/>
-          </a:solidFill>
-          <a:ln w="12700">
-            <a:solidFill>
-              <a:srgbClr val="FFFFFF"/>
-            </a:solidFill>
-            <a:prstDash val="solid"/>
-          </a:ln>
-          <a:effectLst>
-            <a:outerShdw sx="100000" sy="100000" kx="0" ky="0" algn="bl" rotWithShape="0" blurRad="228600" dist="50800" dir="8100000">
-              <a:srgbClr val="000000">
-                <a:alpha val="6000"/>
-              </a:srgbClr>
-            </a:outerShdw>
-          </a:effectLst>
-        </p:spPr>
-      </p:sp>
-      <p:sp>
-        <p:nvSpPr>
-          <p:cNvPr id="12" name="Shape 10"/>
-          <p:cNvSpPr/>
-          <p:nvPr/>
-        </p:nvSpPr>
-        <p:spPr>
-          <a:xfrm>
-            <a:off x="5010912" y="1600200"/>
-            <a:ext cx="109728" cy="109728"/>
-          </a:xfrm>
-          <a:prstGeom prst="rect">
-            <a:avLst/>
-          </a:prstGeom>
-          <a:solidFill>
-            <a:srgbClr val="C7C7CC"/>
-          </a:solidFill>
-          <a:ln w="12700">
-            <a:solidFill>
-              <a:srgbClr val="C7C7CC"/>
-            </a:solidFill>
-            <a:prstDash val="solid"/>
-          </a:ln>
-        </p:spPr>
-      </p:sp>
-      <p:sp>
-        <p:nvSpPr>
-          <p:cNvPr id="13" name="Text 11"/>
-          <p:cNvSpPr/>
-          <p:nvPr/>
-        </p:nvSpPr>
-        <p:spPr>
-          <a:xfrm>
-            <a:off x="5010912" y="1965960"/>
-            <a:ext cx="1554480" cy="457200"/>
-          </a:xfrm>
-          <a:prstGeom prst="rect">
-            <a:avLst/>
-          </a:prstGeom>
-          <a:noFill/>
-          <a:ln/>
-        </p:spPr>
-        <p:txBody>
-          <a:bodyPr wrap="square" lIns="0" tIns="0" rIns="0" bIns="0" rtlCol="0" anchor="ctr"/>
-          <a:lstStyle/>
-          <a:p>
-            <a:pPr indent="0" marL="0">
-              <a:buNone/>
-            </a:pPr>
-            <a:r>
-              <a:rPr lang="en-US" sz="2000" b="1" dirty="0">
-                <a:solidFill>
-                  <a:srgbClr val="111111"/>
-                </a:solidFill>
-                <a:latin typeface="Arial" pitchFamily="34" charset="0"/>
-                <a:ea typeface="Arial" pitchFamily="34" charset="-122"/>
-                <a:cs typeface="Arial" pitchFamily="34" charset="-120"/>
-              </a:rPr>
-              <a:t>人工审核</a:t>
-            </a:r>
-            <a:endParaRPr lang="en-US" sz="2000" dirty="0"/>
-          </a:p>
-        </p:txBody>
-      </p:sp>
-      <p:sp>
-        <p:nvSpPr>
-          <p:cNvPr id="14" name="Text 12"/>
-          <p:cNvSpPr/>
-          <p:nvPr/>
-        </p:nvSpPr>
-        <p:spPr>
-          <a:xfrm>
-            <a:off x="5010912" y="2514600"/>
-            <a:ext cx="1554480" cy="731520"/>
-          </a:xfrm>
-          <a:prstGeom prst="rect">
-            <a:avLst/>
-          </a:prstGeom>
-          <a:noFill/>
-          <a:ln/>
-        </p:spPr>
-        <p:txBody>
-          <a:bodyPr wrap="square" lIns="0" tIns="0" rIns="0" bIns="0" rtlCol="0" anchor="ctr"/>
-          <a:lstStyle/>
-          <a:p>
-            <a:pPr indent="0" marL="0">
-              <a:buNone/>
-            </a:pPr>
-            <a:r>
-              <a:rPr lang="en-US" sz="1300" dirty="0">
-                <a:solidFill>
-                  <a:srgbClr val="8E8E93"/>
-                </a:solidFill>
-                <a:latin typeface="Arial" pitchFamily="34" charset="0"/>
-                <a:ea typeface="Arial" pitchFamily="34" charset="-122"/>
-                <a:cs typeface="Arial" pitchFamily="34" charset="-120"/>
-              </a:rPr>
-              <a:t>审批凭人工经验，</a:t>
-            </a:r>
-            <a:endParaRPr lang="en-US" sz="1300" dirty="0"/>
-          </a:p>
-          <a:p>
-            <a:pPr indent="0" marL="0">
-              <a:buNone/>
-            </a:pPr>
-            <a:r>
-              <a:rPr lang="en-US" sz="1300" dirty="0">
-                <a:solidFill>
-                  <a:srgbClr val="8E8E93"/>
-                </a:solidFill>
-                <a:latin typeface="Arial" pitchFamily="34" charset="0"/>
-                <a:ea typeface="Arial" pitchFamily="34" charset="-122"/>
-                <a:cs typeface="Arial" pitchFamily="34" charset="-120"/>
-              </a:rPr>
-              <a:t>自动化审核更规范</a:t>
-            </a:r>
-            <a:endParaRPr lang="en-US" sz="1300" dirty="0"/>
-          </a:p>
-        </p:txBody>
-      </p:sp>
-      <p:sp>
-        <p:nvSpPr>
-          <p:cNvPr id="15" name="Shape 13"/>
-          <p:cNvSpPr/>
-          <p:nvPr/>
-        </p:nvSpPr>
-        <p:spPr>
-          <a:xfrm>
-            <a:off x="6949440" y="1371600"/>
-            <a:ext cx="1874520" cy="2194560"/>
-          </a:xfrm>
-          <a:prstGeom prst="rect">
-            <a:avLst/>
-          </a:prstGeom>
-          <a:solidFill>
-            <a:srgbClr val="FFFFFF"/>
-          </a:solidFill>
-          <a:ln w="12700">
-            <a:solidFill>
-              <a:srgbClr val="FFFFFF"/>
-            </a:solidFill>
-            <a:prstDash val="solid"/>
-          </a:ln>
-          <a:effectLst>
-            <a:outerShdw sx="100000" sy="100000" kx="0" ky="0" algn="bl" rotWithShape="0" blurRad="228600" dist="50800" dir="8100000">
-              <a:srgbClr val="000000">
-                <a:alpha val="6000"/>
-              </a:srgbClr>
-            </a:outerShdw>
-          </a:effectLst>
-        </p:spPr>
-      </p:sp>
-      <p:sp>
-        <p:nvSpPr>
-          <p:cNvPr id="16" name="Shape 14"/>
-          <p:cNvSpPr/>
-          <p:nvPr/>
-        </p:nvSpPr>
-        <p:spPr>
-          <a:xfrm>
-            <a:off x="7114032" y="1600200"/>
-            <a:ext cx="109728" cy="109728"/>
-          </a:xfrm>
-          <a:prstGeom prst="rect">
-            <a:avLst/>
-          </a:prstGeom>
-          <a:solidFill>
-            <a:srgbClr val="C7C7CC"/>
-          </a:solidFill>
-          <a:ln w="12700">
-            <a:solidFill>
-              <a:srgbClr val="C7C7CC"/>
-            </a:solidFill>
-            <a:prstDash val="solid"/>
-          </a:ln>
-        </p:spPr>
-      </p:sp>
-      <p:sp>
-        <p:nvSpPr>
-          <p:cNvPr id="17" name="Text 15"/>
-          <p:cNvSpPr/>
-          <p:nvPr/>
-        </p:nvSpPr>
-        <p:spPr>
-          <a:xfrm>
-            <a:off x="7114032" y="1965960"/>
-            <a:ext cx="1554480" cy="457200"/>
-          </a:xfrm>
-          <a:prstGeom prst="rect">
-            <a:avLst/>
-          </a:prstGeom>
-          <a:noFill/>
-          <a:ln/>
-        </p:spPr>
-        <p:txBody>
-          <a:bodyPr wrap="square" lIns="0" tIns="0" rIns="0" bIns="0" rtlCol="0" anchor="ctr"/>
-          <a:lstStyle/>
-          <a:p>
-            <a:pPr indent="0" marL="0">
-              <a:buNone/>
-            </a:pPr>
-            <a:r>
-              <a:rPr lang="en-US" sz="2000" b="1" dirty="0">
-                <a:solidFill>
-                  <a:srgbClr val="111111"/>
-                </a:solidFill>
-                <a:latin typeface="Arial" pitchFamily="34" charset="0"/>
-                <a:ea typeface="Arial" pitchFamily="34" charset="-122"/>
-                <a:cs typeface="Arial" pitchFamily="34" charset="-120"/>
-              </a:rPr>
-              <a:t>数据沉睡</a:t>
-            </a:r>
-            <a:endParaRPr lang="en-US" sz="2000" dirty="0"/>
-          </a:p>
-        </p:txBody>
-      </p:sp>
-      <p:sp>
-        <p:nvSpPr>
-          <p:cNvPr id="18" name="Text 16"/>
-          <p:cNvSpPr/>
-          <p:nvPr/>
-        </p:nvSpPr>
-        <p:spPr>
-          <a:xfrm>
-            <a:off x="7114032" y="2514600"/>
-            <a:ext cx="1554480" cy="731520"/>
-          </a:xfrm>
-          <a:prstGeom prst="rect">
-            <a:avLst/>
-          </a:prstGeom>
-          <a:noFill/>
-          <a:ln/>
-        </p:spPr>
-        <p:txBody>
-          <a:bodyPr wrap="square" lIns="0" tIns="0" rIns="0" bIns="0" rtlCol="0" anchor="ctr"/>
-          <a:lstStyle/>
-          <a:p>
-            <a:pPr indent="0" marL="0">
-              <a:buNone/>
-            </a:pPr>
-            <a:r>
-              <a:rPr lang="en-US" sz="1300" dirty="0">
-                <a:solidFill>
-                  <a:srgbClr val="8E8E93"/>
-                </a:solidFill>
-                <a:latin typeface="Arial" pitchFamily="34" charset="0"/>
-                <a:ea typeface="Arial" pitchFamily="34" charset="-122"/>
-                <a:cs typeface="Arial" pitchFamily="34" charset="-120"/>
-              </a:rPr>
-              <a:t>纸质归档，无法统计隐患</a:t>
-            </a:r>
-            <a:endParaRPr lang="en-US" sz="1300" dirty="0"/>
+            <a:pPr algn="ctr" indent="0" marL="0">
+              <a:buNone/>
+            </a:pPr>
+            <a:r>
+              <a:rPr lang="en-US" sz="2200" dirty="0">
+                <a:solidFill>
+                  <a:srgbClr val="3A3A3C"/>
+                </a:solidFill>
+                <a:latin typeface="Arial" pitchFamily="34" charset="0"/>
+                <a:ea typeface="Arial" pitchFamily="34" charset="-122"/>
+                <a:cs typeface="Arial" pitchFamily="34" charset="-120"/>
+              </a:rPr>
+              <a:t>60 秒完成识别 · 校验 · 审批建议</a:t>
+            </a:r>
+            <a:endParaRPr lang="en-US" sz="2200" dirty="0"/>
           </a:p>
         </p:txBody>
       </p:sp>
@@ -3604,7 +3604,7 @@
                 <a:ea typeface="Arial" pitchFamily="34" charset="-122"/>
                 <a:cs typeface="Arial" pitchFamily="34" charset="-120"/>
               </a:rPr>
-              <a:t>一句话，跑通全流程。</a:t>
+              <a:t>自动化跑通全流程。</a:t>
             </a:r>
             <a:endParaRPr lang="en-US" sz="2600" dirty="0"/>
           </a:p>
@@ -4965,7 +4965,7 @@
         <p:spPr>
           <a:xfrm>
             <a:off x="640080" y="1828800"/>
-            <a:ext cx="4114800" cy="457200"/>
+            <a:ext cx="4114800" cy="640080"/>
           </a:xfrm>
           <a:prstGeom prst="rect">
             <a:avLst/>
@@ -4981,7 +4981,7 @@
               <a:buNone/>
             </a:pPr>
             <a:r>
-              <a:rPr lang="en-US" sz="1500" dirty="0">
+              <a:rPr lang="en-US" sz="1400" dirty="0">
                 <a:solidFill>
                   <a:srgbClr val="8E8E93"/>
                 </a:solidFill>
@@ -4989,9 +4989,9 @@
                 <a:ea typeface="Arial" pitchFamily="34" charset="-122"/>
                 <a:cs typeface="Arial" pitchFamily="34" charset="-120"/>
               </a:rPr>
-              <a:t>从人工传递、人工审核，到 15 秒闭环。</a:t>
-            </a:r>
-            <a:endParaRPr lang="en-US" sz="1500" dirty="0"/>
+              <a:t>从原人工传递、人工审核，现在自动化线上 60s 完成闭环。</a:t>
+            </a:r>
+            <a:endParaRPr lang="en-US" sz="1400" dirty="0"/>
           </a:p>
         </p:txBody>
       </p:sp>
@@ -5542,8 +5542,8 @@
         </p:nvSpPr>
         <p:spPr>
           <a:xfrm>
-            <a:off x="7955280" y="3840480"/>
-            <a:ext cx="640080" cy="228600"/>
+            <a:off x="7818120" y="3840480"/>
+            <a:ext cx="822960" cy="228600"/>
           </a:xfrm>
           <a:prstGeom prst="rect">
             <a:avLst/>
@@ -5567,7 +5567,7 @@
                 <a:ea typeface="Arial" pitchFamily="34" charset="-122"/>
                 <a:cs typeface="Arial" pitchFamily="34" charset="-120"/>
               </a:rPr>
-              <a:t>15 s</a:t>
+              <a:t>60s</a:t>
             </a:r>
             <a:endParaRPr lang="en-US" sz="1000" dirty="0"/>
           </a:p>
@@ -7501,7 +7501,7 @@
                 <a:ea typeface="Arial" pitchFamily="34" charset="-122"/>
                 <a:cs typeface="Arial" pitchFamily="34" charset="-120"/>
               </a:rPr>
-              <a:t>二级无隐患自动过</a:t>
+              <a:t>二级无异常自动过</a:t>
             </a:r>
             <a:endParaRPr lang="en-US" sz="1200" dirty="0"/>
           </a:p>
@@ -8101,7 +8101,7 @@
                 <a:ea typeface="Arial" pitchFamily="34" charset="-122"/>
                 <a:cs typeface="Arial" pitchFamily="34" charset="-120"/>
               </a:rPr>
-              <a:t>隐患处置</a:t>
+              <a:t>问题处置</a:t>
             </a:r>
             <a:endParaRPr lang="en-US" sz="1500" dirty="0"/>
           </a:p>
@@ -8140,7 +8140,7 @@
                 <a:ea typeface="Arial" pitchFamily="34" charset="-122"/>
                 <a:cs typeface="Arial" pitchFamily="34" charset="-120"/>
               </a:rPr>
-              <a:t>× 与空白记隐患，推送钉钉介入</a:t>
+              <a:t>× 与空白记异常，推送钉钉介入</a:t>
             </a:r>
             <a:endParaRPr lang="en-US" sz="1400" dirty="0"/>
           </a:p>

</xml_diff>